<commit_message>
Correct graduate course: build syllabus/schedule/admin, switch to course-wide Assignments/Midterm/Final structure, remove per-module homework, fix video policy and cross-course references in Modules 1-2
</commit_message>
<xml_diff>
--- a/Sports-Analytics-Graduate/01_Getting_Started_with_Advanced_Basketball_Analytics/Lecture_Slides/Module01_Getting_Started_with_Advanced_Basketball_Analytics.pptx
+++ b/Sports-Analytics-Graduate/01_Getting_Started_with_Advanced_Basketball_Analytics/Lecture_Slides/Module01_Getting_Started_with_Advanced_Basketball_Analytics.pptx
@@ -18,8 +18,6 @@
     <p:sldId id="266" r:id="rId12"/>
     <p:sldId id="267" r:id="rId13"/>
     <p:sldId id="268" r:id="rId14"/>
-    <p:sldId id="269" r:id="rId15"/>
-    <p:sldId id="270" r:id="rId16"/>
     <p:sldId id="271" r:id="rId17"/>
     <p:sldId id="272" r:id="rId18"/>
     <p:sldId id="273" r:id="rId19"/>
@@ -38,7 +36,6 @@
     <p:sldId id="286" r:id="rId32"/>
     <p:sldId id="287" r:id="rId33"/>
     <p:sldId id="288" r:id="rId34"/>
-    <p:sldId id="289" r:id="rId35"/>
     <p:sldId id="290" r:id="rId36"/>
     <p:sldId id="291" r:id="rId37"/>
     <p:sldId id="292" r:id="rId38"/>
@@ -804,7 +801,7 @@
           <a:p>
             <a:r>
               <a:rPr lang="en-US" dirty="0"/>
-              <a:t>Discussion: this is the same leaderboard style you built in the undergraduate course. Ask the class what this table can't tell you about a player's actual value to a team -- use it to set up why we're about to look at assist NETWORKS instead of single-number leaderboards. Timing: about 5 minutes.</a:t>
+              <a:t>Discussion: point out that a single leaderboard number hides a lot about how a player actually produces those points. Ask the class what this table can't tell you about a player's actual value to a team -- use it to set up why we're about to look at assist NETWORKS instead of single-number leaderboards. Timing: about 5 minutes.</a:t>
             </a:r>
             <a:endParaRPr lang="en-US" dirty="0"/>
           </a:p>
@@ -934,182 +931,6 @@
 </p:notes>
 </file>
 
-<file path=ppt/notesSlides/notesSlide14.xml><?xml version="1.0" encoding="utf-8"?>
-<p:notes xmlns:a="http://schemas.openxmlformats.org/drawingml/2006/main" xmlns:r="http://schemas.openxmlformats.org/officeDocument/2006/relationships" xmlns:p="http://schemas.openxmlformats.org/presentationml/2006/main">
-  <p:cSld>
-    <p:spTree>
-      <p:nvGrpSpPr>
-        <p:cNvPr id="1" name=""/>
-        <p:cNvGrpSpPr/>
-        <p:nvPr/>
-      </p:nvGrpSpPr>
-      <p:grpSpPr>
-        <a:xfrm>
-          <a:off x="0" y="0"/>
-          <a:ext cx="0" cy="0"/>
-          <a:chOff x="0" y="0"/>
-          <a:chExt cx="0" cy="0"/>
-        </a:xfrm>
-      </p:grpSpPr>
-      <p:sp>
-        <p:nvSpPr>
-          <p:cNvPr id="2" name="Slide Image Placeholder 1"/>
-          <p:cNvSpPr>
-            <a:spLocks noGrp="1" noRot="1" noChangeAspect="1"/>
-          </p:cNvSpPr>
-          <p:nvPr>
-            <p:ph type="sldImg"/>
-          </p:nvPr>
-        </p:nvSpPr>
-        <p:spPr/>
-      </p:sp>
-      <p:sp>
-        <p:nvSpPr>
-          <p:cNvPr id="3" name="Notes Placeholder 2"/>
-          <p:cNvSpPr>
-            <a:spLocks noGrp="1"/>
-          </p:cNvSpPr>
-          <p:nvPr>
-            <p:ph type="body" idx="1"/>
-          </p:nvPr>
-        </p:nvSpPr>
-        <p:spPr/>
-        <p:txBody>
-          <a:bodyPr/>
-          <a:lstStyle/>
-          <a:p>
-            <a:r>
-              <a:rPr lang="en-US" dirty="0"/>
-              <a:t/>
-            </a:r>
-            <a:endParaRPr lang="en-US" dirty="0"/>
-          </a:p>
-        </p:txBody>
-      </p:sp>
-      <p:sp>
-        <p:nvSpPr>
-          <p:cNvPr id="4" name="Slide Number Placeholder 3"/>
-          <p:cNvSpPr>
-            <a:spLocks noGrp="1"/>
-          </p:cNvSpPr>
-          <p:nvPr>
-            <p:ph type="sldNum" sz="quarter" idx="10"/>
-          </p:nvPr>
-        </p:nvSpPr>
-        <p:spPr/>
-        <p:txBody>
-          <a:bodyPr/>
-          <a:lstStyle/>
-          <a:p>
-            <a:fld id="{F7021451-1387-4CA6-816F-3879F97B5CBC}" type="slidenum">
-              <a:rPr lang="en-US"/>
-              <a:t>14</a:t>
-            </a:fld>
-            <a:endParaRPr lang="en-US"/>
-          </a:p>
-        </p:txBody>
-      </p:sp>
-    </p:spTree>
-    <p:extLst>
-      <p:ext uri="{BB962C8B-B14F-4D97-AF65-F5344CB8AC3E}">
-        <p14:creationId xmlns:p14="http://schemas.microsoft.com/office/powerpoint/2010/main" val="1024086991"/>
-      </p:ext>
-    </p:extLst>
-  </p:cSld>
-  <p:clrMapOvr>
-    <a:masterClrMapping/>
-  </p:clrMapOvr>
-</p:notes>
-</file>
-
-<file path=ppt/notesSlides/notesSlide15.xml><?xml version="1.0" encoding="utf-8"?>
-<p:notes xmlns:a="http://schemas.openxmlformats.org/drawingml/2006/main" xmlns:r="http://schemas.openxmlformats.org/officeDocument/2006/relationships" xmlns:p="http://schemas.openxmlformats.org/presentationml/2006/main">
-  <p:cSld>
-    <p:spTree>
-      <p:nvGrpSpPr>
-        <p:cNvPr id="1" name=""/>
-        <p:cNvGrpSpPr/>
-        <p:nvPr/>
-      </p:nvGrpSpPr>
-      <p:grpSpPr>
-        <a:xfrm>
-          <a:off x="0" y="0"/>
-          <a:ext cx="0" cy="0"/>
-          <a:chOff x="0" y="0"/>
-          <a:chExt cx="0" cy="0"/>
-        </a:xfrm>
-      </p:grpSpPr>
-      <p:sp>
-        <p:nvSpPr>
-          <p:cNvPr id="2" name="Slide Image Placeholder 1"/>
-          <p:cNvSpPr>
-            <a:spLocks noGrp="1" noRot="1" noChangeAspect="1"/>
-          </p:cNvSpPr>
-          <p:nvPr>
-            <p:ph type="sldImg"/>
-          </p:nvPr>
-        </p:nvSpPr>
-        <p:spPr/>
-      </p:sp>
-      <p:sp>
-        <p:nvSpPr>
-          <p:cNvPr id="3" name="Notes Placeholder 2"/>
-          <p:cNvSpPr>
-            <a:spLocks noGrp="1"/>
-          </p:cNvSpPr>
-          <p:nvPr>
-            <p:ph type="body" idx="1"/>
-          </p:nvPr>
-        </p:nvSpPr>
-        <p:spPr/>
-        <p:txBody>
-          <a:bodyPr/>
-          <a:lstStyle/>
-          <a:p>
-            <a:r>
-              <a:rPr lang="en-US" dirty="0"/>
-              <a:t/>
-            </a:r>
-            <a:endParaRPr lang="en-US" dirty="0"/>
-          </a:p>
-        </p:txBody>
-      </p:sp>
-      <p:sp>
-        <p:nvSpPr>
-          <p:cNvPr id="4" name="Slide Number Placeholder 3"/>
-          <p:cNvSpPr>
-            <a:spLocks noGrp="1"/>
-          </p:cNvSpPr>
-          <p:nvPr>
-            <p:ph type="sldNum" sz="quarter" idx="10"/>
-          </p:nvPr>
-        </p:nvSpPr>
-        <p:spPr/>
-        <p:txBody>
-          <a:bodyPr/>
-          <a:lstStyle/>
-          <a:p>
-            <a:fld id="{F7021451-1387-4CA6-816F-3879F97B5CBC}" type="slidenum">
-              <a:rPr lang="en-US"/>
-              <a:t>15</a:t>
-            </a:fld>
-            <a:endParaRPr lang="en-US"/>
-          </a:p>
-        </p:txBody>
-      </p:sp>
-    </p:spTree>
-    <p:extLst>
-      <p:ext uri="{BB962C8B-B14F-4D97-AF65-F5344CB8AC3E}">
-        <p14:creationId xmlns:p14="http://schemas.microsoft.com/office/powerpoint/2010/main" val="1024086991"/>
-      </p:ext>
-    </p:extLst>
-  </p:cSld>
-  <p:clrMapOvr>
-    <a:masterClrMapping/>
-  </p:clrMapOvr>
-</p:notes>
-</file>
-
 <file path=ppt/notesSlides/notesSlide16.xml><?xml version="1.0" encoding="utf-8"?>
 <p:notes xmlns:a="http://schemas.openxmlformats.org/drawingml/2006/main" xmlns:r="http://schemas.openxmlformats.org/officeDocument/2006/relationships" xmlns:p="http://schemas.openxmlformats.org/presentationml/2006/main">
   <p:cSld>
@@ -2852,94 +2673,6 @@
             <a:fld id="{F7021451-1387-4CA6-816F-3879F97B5CBC}" type="slidenum">
               <a:rPr lang="en-US"/>
               <a:t>33</a:t>
-            </a:fld>
-            <a:endParaRPr lang="en-US"/>
-          </a:p>
-        </p:txBody>
-      </p:sp>
-    </p:spTree>
-    <p:extLst>
-      <p:ext uri="{BB962C8B-B14F-4D97-AF65-F5344CB8AC3E}">
-        <p14:creationId xmlns:p14="http://schemas.microsoft.com/office/powerpoint/2010/main" val="1024086991"/>
-      </p:ext>
-    </p:extLst>
-  </p:cSld>
-  <p:clrMapOvr>
-    <a:masterClrMapping/>
-  </p:clrMapOvr>
-</p:notes>
-</file>
-
-<file path=ppt/notesSlides/notesSlide34.xml><?xml version="1.0" encoding="utf-8"?>
-<p:notes xmlns:a="http://schemas.openxmlformats.org/drawingml/2006/main" xmlns:r="http://schemas.openxmlformats.org/officeDocument/2006/relationships" xmlns:p="http://schemas.openxmlformats.org/presentationml/2006/main">
-  <p:cSld>
-    <p:spTree>
-      <p:nvGrpSpPr>
-        <p:cNvPr id="1" name=""/>
-        <p:cNvGrpSpPr/>
-        <p:nvPr/>
-      </p:nvGrpSpPr>
-      <p:grpSpPr>
-        <a:xfrm>
-          <a:off x="0" y="0"/>
-          <a:ext cx="0" cy="0"/>
-          <a:chOff x="0" y="0"/>
-          <a:chExt cx="0" cy="0"/>
-        </a:xfrm>
-      </p:grpSpPr>
-      <p:sp>
-        <p:nvSpPr>
-          <p:cNvPr id="2" name="Slide Image Placeholder 1"/>
-          <p:cNvSpPr>
-            <a:spLocks noGrp="1" noRot="1" noChangeAspect="1"/>
-          </p:cNvSpPr>
-          <p:nvPr>
-            <p:ph type="sldImg"/>
-          </p:nvPr>
-        </p:nvSpPr>
-        <p:spPr/>
-      </p:sp>
-      <p:sp>
-        <p:nvSpPr>
-          <p:cNvPr id="3" name="Notes Placeholder 2"/>
-          <p:cNvSpPr>
-            <a:spLocks noGrp="1"/>
-          </p:cNvSpPr>
-          <p:nvPr>
-            <p:ph type="body" idx="1"/>
-          </p:nvPr>
-        </p:nvSpPr>
-        <p:spPr/>
-        <p:txBody>
-          <a:bodyPr/>
-          <a:lstStyle/>
-          <a:p>
-            <a:r>
-              <a:rPr lang="en-US" dirty="0"/>
-              <a:t/>
-            </a:r>
-            <a:endParaRPr lang="en-US" dirty="0"/>
-          </a:p>
-        </p:txBody>
-      </p:sp>
-      <p:sp>
-        <p:nvSpPr>
-          <p:cNvPr id="4" name="Slide Number Placeholder 3"/>
-          <p:cNvSpPr>
-            <a:spLocks noGrp="1"/>
-          </p:cNvSpPr>
-          <p:nvPr>
-            <p:ph type="sldNum" sz="quarter" idx="10"/>
-          </p:nvPr>
-        </p:nvSpPr>
-        <p:spPr/>
-        <p:txBody>
-          <a:bodyPr/>
-          <a:lstStyle/>
-          <a:p>
-            <a:fld id="{F7021451-1387-4CA6-816F-3879F97B5CBC}" type="slidenum">
-              <a:rPr lang="en-US"/>
-              <a:t>34</a:t>
             </a:fld>
             <a:endParaRPr lang="en-US"/>
           </a:p>
@@ -6465,520 +6198,6 @@
 </p:sld>
 </file>
 
-<file path=ppt/slides/slide14.xml><?xml version="1.0" encoding="utf-8"?>
-<p:sld xmlns:a="http://schemas.openxmlformats.org/drawingml/2006/main" xmlns:r="http://schemas.openxmlformats.org/officeDocument/2006/relationships" xmlns:p="http://schemas.openxmlformats.org/presentationml/2006/main">
-  <p:cSld name="Slide 14">
-    <p:bg>
-      <p:bgPr>
-        <a:solidFill>
-          <a:srgbClr val="FFFFFF"/>
-        </a:solidFill>
-      </p:bgPr>
-    </p:bg>
-    <p:spTree>
-      <p:nvGrpSpPr>
-        <p:cNvPr id="1" name=""/>
-        <p:cNvGrpSpPr/>
-        <p:nvPr/>
-      </p:nvGrpSpPr>
-      <p:grpSpPr>
-        <a:xfrm>
-          <a:off x="0" y="0"/>
-          <a:ext cx="0" cy="0"/>
-          <a:chOff x="0" y="0"/>
-          <a:chExt cx="0" cy="0"/>
-        </a:xfrm>
-      </p:grpSpPr>
-      <p:sp>
-        <p:nvSpPr>
-          <p:cNvPr id="2" name="Text 0"/>
-          <p:cNvSpPr txBox="1"/>
-          <p:nvPr/>
-        </p:nvSpPr>
-        <p:spPr>
-          <a:xfrm>
-            <a:off x="548640" y="411480"/>
-            <a:ext cx="11091672" cy="320040"/>
-          </a:xfrm>
-          <a:prstGeom prst="rect">
-            <a:avLst/>
-          </a:prstGeom>
-          <a:noFill/>
-          <a:ln/>
-        </p:spPr>
-        <p:txBody>
-          <a:bodyPr wrap="square" lIns="0" tIns="0" rIns="0" bIns="0" rtlCol="0" anchor="ctr"/>
-          <a:lstStyle/>
-          <a:p>
-            <a:pPr indent="0" marL="0">
-              <a:buNone/>
-            </a:pPr>
-            <a:r>
-              <a:rPr lang="en-US" sz="1300" b="1" spc="200" kern="0" dirty="0">
-                <a:solidFill>
-                  <a:srgbClr val="E4572E"/>
-                </a:solidFill>
-                <a:latin typeface="Calibri" pitchFamily="34" charset="0"/>
-                <a:ea typeface="Calibri" pitchFamily="34" charset="-122"/>
-                <a:cs typeface="Calibri" pitchFamily="34" charset="-120"/>
-              </a:rPr>
-              <a:t>VIDEO · GETTING COMFORTABLE WITH DPLYR</a:t>
-            </a:r>
-            <a:endParaRPr lang="en-US" sz="1300" dirty="0"/>
-          </a:p>
-        </p:txBody>
-      </p:sp>
-      <p:sp>
-        <p:nvSpPr>
-          <p:cNvPr id="3" name="Text 1"/>
-          <p:cNvSpPr txBox="1"/>
-          <p:nvPr/>
-        </p:nvSpPr>
-        <p:spPr>
-          <a:xfrm>
-            <a:off x="548640" y="960120"/>
-            <a:ext cx="11091672" cy="914400"/>
-          </a:xfrm>
-          <a:prstGeom prst="rect">
-            <a:avLst/>
-          </a:prstGeom>
-          <a:noFill/>
-          <a:ln/>
-        </p:spPr>
-        <p:txBody>
-          <a:bodyPr wrap="square" lIns="0" tIns="0" rIns="0" bIns="0" rtlCol="0" anchor="ctr"/>
-          <a:lstStyle/>
-          <a:p>
-            <a:pPr indent="0" marL="0">
-              <a:buNone/>
-            </a:pPr>
-            <a:r>
-              <a:rPr lang="en-US" sz="2800" b="1" dirty="0">
-                <a:solidFill>
-                  <a:srgbClr val="16213E"/>
-                </a:solidFill>
-                <a:latin typeface="Cambria" pitchFamily="34" charset="0"/>
-                <a:ea typeface="Cambria" pitchFamily="34" charset="-122"/>
-                <a:cs typeface="Cambria" pitchFamily="34" charset="-120"/>
-              </a:rPr>
-              <a:t>If The Pipeline Syntax Feels New</a:t>
-            </a:r>
-            <a:endParaRPr lang="en-US" sz="2800" dirty="0"/>
-          </a:p>
-        </p:txBody>
-      </p:sp>
-      <p:sp>
-        <p:nvSpPr>
-          <p:cNvPr id="4" name="Text 2"/>
-          <p:cNvSpPr txBox="1"/>
-          <p:nvPr/>
-        </p:nvSpPr>
-        <p:spPr>
-          <a:xfrm>
-            <a:off x="548640" y="1920240"/>
-            <a:ext cx="11091672" cy="914400"/>
-          </a:xfrm>
-          <a:prstGeom prst="rect">
-            <a:avLst/>
-          </a:prstGeom>
-          <a:noFill/>
-          <a:ln/>
-        </p:spPr>
-        <p:txBody>
-          <a:bodyPr wrap="square" lIns="0" tIns="0" rIns="0" bIns="0" rtlCol="0" anchor="t"/>
-          <a:lstStyle/>
-          <a:p>
-            <a:pPr indent="0" marL="0">
-              <a:lnSpc>
-                <a:spcPct val="125000"/>
-              </a:lnSpc>
-              <a:buNone/>
-            </a:pPr>
-            <a:r>
-              <a:rPr lang="en-US" sz="1600" dirty="0">
-                <a:solidFill>
-                  <a:srgbClr val="16213E"/>
-                </a:solidFill>
-                <a:latin typeface="Calibri" pitchFamily="34" charset="0"/>
-                <a:ea typeface="Calibri" pitchFamily="34" charset="-122"/>
-                <a:cs typeface="Calibri" pitchFamily="34" charset="-120"/>
-              </a:rPr>
-              <a:t>We just used four dplyr verbs in one pipeline. If %&gt;%, filter(), mutate(), and arrange() are new to you, this short video walks through exactly those verbs before we go further.</a:t>
-            </a:r>
-            <a:endParaRPr lang="en-US" sz="1600" dirty="0"/>
-          </a:p>
-        </p:txBody>
-      </p:sp>
-    </p:spTree>
-  </p:cSld>
-  <p:clrMapOvr>
-    <a:masterClrMapping/>
-  </p:clrMapOvr>
-  <p:transition xmlns:p="http://schemas.openxmlformats.org/presentationml/2006/main" spd="med">
-    <p:fade/>
-  </p:transition>
-</p:sld>
-</file>
-
-<file path=ppt/slides/slide15.xml><?xml version="1.0" encoding="utf-8"?>
-<p:sld xmlns:a="http://schemas.openxmlformats.org/drawingml/2006/main" xmlns:r="http://schemas.openxmlformats.org/officeDocument/2006/relationships" xmlns:p="http://schemas.openxmlformats.org/presentationml/2006/main">
-  <p:cSld name="Slide 15">
-    <p:bg>
-      <p:bgPr>
-        <a:solidFill>
-          <a:srgbClr val="FFFFFF"/>
-        </a:solidFill>
-      </p:bgPr>
-    </p:bg>
-    <p:spTree>
-      <p:nvGrpSpPr>
-        <p:cNvPr id="1" name=""/>
-        <p:cNvGrpSpPr/>
-        <p:nvPr/>
-      </p:nvGrpSpPr>
-      <p:grpSpPr>
-        <a:xfrm>
-          <a:off x="0" y="0"/>
-          <a:ext cx="0" cy="0"/>
-          <a:chOff x="0" y="0"/>
-          <a:chExt cx="0" cy="0"/>
-        </a:xfrm>
-      </p:grpSpPr>
-      <p:sp>
-        <p:nvSpPr>
-          <p:cNvPr id="2" name="Text 0"/>
-          <p:cNvSpPr txBox="1"/>
-          <p:nvPr/>
-        </p:nvSpPr>
-        <p:spPr>
-          <a:xfrm>
-            <a:off x="548640" y="411480"/>
-            <a:ext cx="11091672" cy="320040"/>
-          </a:xfrm>
-          <a:prstGeom prst="rect">
-            <a:avLst/>
-          </a:prstGeom>
-          <a:noFill/>
-          <a:ln/>
-        </p:spPr>
-        <p:txBody>
-          <a:bodyPr wrap="square" lIns="0" tIns="0" rIns="0" bIns="0" rtlCol="0" anchor="ctr"/>
-          <a:lstStyle/>
-          <a:p>
-            <a:pPr indent="0" marL="0">
-              <a:buNone/>
-            </a:pPr>
-            <a:r>
-              <a:rPr lang="en-US" sz="1300" b="1" spc="200" kern="0" dirty="0">
-                <a:solidFill>
-                  <a:srgbClr val="E4572E"/>
-                </a:solidFill>
-                <a:latin typeface="Calibri" pitchFamily="34" charset="0"/>
-                <a:ea typeface="Calibri" pitchFamily="34" charset="-122"/>
-                <a:cs typeface="Calibri" pitchFamily="34" charset="-120"/>
-              </a:rPr>
-              <a:t>VIDEO</a:t>
-            </a:r>
-            <a:endParaRPr lang="en-US" sz="1300" dirty="0"/>
-          </a:p>
-        </p:txBody>
-      </p:sp>
-      <p:sp>
-        <p:nvSpPr>
-          <p:cNvPr id="3" name="Text 1"/>
-          <p:cNvSpPr txBox="1"/>
-          <p:nvPr/>
-        </p:nvSpPr>
-        <p:spPr>
-          <a:xfrm>
-            <a:off x="548640" y="960120"/>
-            <a:ext cx="11091672" cy="914400"/>
-          </a:xfrm>
-          <a:prstGeom prst="rect">
-            <a:avLst/>
-          </a:prstGeom>
-          <a:noFill/>
-          <a:ln/>
-        </p:spPr>
-        <p:txBody>
-          <a:bodyPr wrap="square" lIns="0" tIns="0" rIns="0" bIns="0" rtlCol="0" anchor="ctr"/>
-          <a:lstStyle/>
-          <a:p>
-            <a:pPr indent="0" marL="0">
-              <a:buNone/>
-            </a:pPr>
-            <a:r>
-              <a:rPr lang="en-US" sz="2800" b="1" dirty="0">
-                <a:solidFill>
-                  <a:srgbClr val="16213E"/>
-                </a:solidFill>
-                <a:latin typeface="Cambria" pitchFamily="34" charset="0"/>
-                <a:ea typeface="Cambria" pitchFamily="34" charset="-122"/>
-                <a:cs typeface="Cambria" pitchFamily="34" charset="-120"/>
-              </a:rPr>
-              <a:t>dplyr Basics</a:t>
-            </a:r>
-            <a:endParaRPr lang="en-US" sz="2800" dirty="0"/>
-          </a:p>
-        </p:txBody>
-      </p:sp>
-      <p:sp>
-        <p:nvSpPr>
-          <p:cNvPr id="4" name="Shape 2"/>
-          <p:cNvSpPr/>
-          <p:nvPr/>
-        </p:nvSpPr>
-        <p:spPr>
-          <a:xfrm>
-            <a:off x="548640" y="1965960"/>
-            <a:ext cx="11091672" cy="3108960"/>
-          </a:xfrm>
-          <a:prstGeom prst="roundRect">
-            <a:avLst>
-              <a:gd name="adj" fmla="val 1765"/>
-            </a:avLst>
-          </a:prstGeom>
-          <a:solidFill>
-            <a:srgbClr val="0B1D33"/>
-          </a:solidFill>
-          <a:ln/>
-        </p:spPr>
-      </p:sp>
-      <p:sp>
-        <p:nvSpPr>
-          <p:cNvPr id="5" name="Shape 3"/>
-          <p:cNvSpPr/>
-          <p:nvPr/>
-        </p:nvSpPr>
-        <p:spPr>
-          <a:xfrm>
-            <a:off x="5591556" y="2377440"/>
-            <a:ext cx="1005840" cy="1005840"/>
-          </a:xfrm>
-          <a:prstGeom prst="ellipse">
-            <a:avLst/>
-          </a:prstGeom>
-          <a:solidFill>
-            <a:srgbClr val="E4572E"/>
-          </a:solidFill>
-          <a:ln/>
-        </p:spPr>
-      </p:sp>
-      <p:sp>
-        <p:nvSpPr>
-          <p:cNvPr id="6" name="Text 4"/>
-          <p:cNvSpPr txBox="1"/>
-          <p:nvPr/>
-        </p:nvSpPr>
-        <p:spPr>
-          <a:xfrm>
-            <a:off x="5591556" y="2377440"/>
-            <a:ext cx="1005840" cy="1005840"/>
-          </a:xfrm>
-          <a:prstGeom prst="rect">
-            <a:avLst/>
-          </a:prstGeom>
-          <a:noFill/>
-          <a:ln/>
-        </p:spPr>
-        <p:txBody>
-          <a:bodyPr wrap="square" lIns="0" tIns="0" rIns="0" bIns="0" rtlCol="0" anchor="ctr"/>
-          <a:lstStyle/>
-          <a:p>
-            <a:pPr algn="ctr" indent="0" marL="0">
-              <a:buNone/>
-            </a:pPr>
-            <a:r>
-              <a:rPr lang="en-US" sz="3200" dirty="0">
-                <a:solidFill>
-                  <a:srgbClr val="FFFFFF"/>
-                </a:solidFill>
-              </a:rPr>
-              <a:t>▶</a:t>
-            </a:r>
-            <a:endParaRPr lang="en-US" sz="3200" dirty="0"/>
-          </a:p>
-        </p:txBody>
-      </p:sp>
-      <p:sp>
-        <p:nvSpPr>
-          <p:cNvPr id="7" name="Text 5"/>
-          <p:cNvSpPr txBox="1"/>
-          <p:nvPr/>
-        </p:nvSpPr>
-        <p:spPr>
-          <a:xfrm>
-            <a:off x="1097280" y="3520440"/>
-            <a:ext cx="9994392" cy="502920"/>
-          </a:xfrm>
-          <a:prstGeom prst="rect">
-            <a:avLst/>
-          </a:prstGeom>
-          <a:noFill/>
-          <a:ln/>
-        </p:spPr>
-        <p:txBody>
-          <a:bodyPr wrap="square" lIns="0" tIns="0" rIns="0" bIns="0" rtlCol="0" anchor="ctr"/>
-          <a:lstStyle/>
-          <a:p>
-            <a:pPr algn="ctr" indent="0" marL="0">
-              <a:buNone/>
-            </a:pPr>
-            <a:r>
-              <a:rPr lang="en-US" sz="2000" b="1" dirty="0">
-                <a:solidFill>
-                  <a:srgbClr val="FFFFFF"/>
-                </a:solidFill>
-                <a:latin typeface="Cambria" pitchFamily="34" charset="0"/>
-                <a:ea typeface="Cambria" pitchFamily="34" charset="-122"/>
-                <a:cs typeface="Cambria" pitchFamily="34" charset="-120"/>
-              </a:rPr>
-              <a:t>R PROGRAMMING dplyr BASICS -- summarize, group_by, select, mutate, filter, arrange</a:t>
-            </a:r>
-            <a:endParaRPr lang="en-US" sz="2000" dirty="0"/>
-          </a:p>
-        </p:txBody>
-      </p:sp>
-      <p:sp>
-        <p:nvSpPr>
-          <p:cNvPr id="8" name="Text 6"/>
-          <p:cNvSpPr txBox="1"/>
-          <p:nvPr/>
-        </p:nvSpPr>
-        <p:spPr>
-          <a:xfrm>
-            <a:off x="1097280" y="3977640"/>
-            <a:ext cx="9994392" cy="365760"/>
-          </a:xfrm>
-          <a:prstGeom prst="rect">
-            <a:avLst/>
-          </a:prstGeom>
-          <a:noFill/>
-          <a:ln/>
-        </p:spPr>
-        <p:txBody>
-          <a:bodyPr wrap="square" lIns="0" tIns="0" rIns="0" bIns="0" rtlCol="0" anchor="ctr"/>
-          <a:lstStyle/>
-          <a:p>
-            <a:pPr algn="ctr" indent="0" marL="0">
-              <a:buNone/>
-            </a:pPr>
-            <a:r>
-              <a:rPr lang="en-US" sz="1300" dirty="0">
-                <a:solidFill>
-                  <a:srgbClr val="AEBBD1"/>
-                </a:solidFill>
-                <a:latin typeface="Calibri" pitchFamily="34" charset="0"/>
-                <a:ea typeface="Calibri" pitchFamily="34" charset="-122"/>
-                <a:cs typeface="Calibri" pitchFamily="34" charset="-120"/>
-              </a:rPr>
-              <a:t>YouTube (exact channel/runtime not independently confirmed)</a:t>
-            </a:r>
-            <a:endParaRPr lang="en-US" sz="1300" dirty="0"/>
-          </a:p>
-        </p:txBody>
-      </p:sp>
-      <p:sp>
-        <p:nvSpPr>
-          <p:cNvPr id="9" name="Text 7">
-            <a:hlinkClick r:id="rId1" tooltip=""/>
-          </p:cNvPr>
-          <p:cNvSpPr txBox="1"/>
-          <p:nvPr/>
-        </p:nvSpPr>
-        <p:spPr>
-          <a:xfrm>
-            <a:off x="1097280" y="4343400"/>
-            <a:ext cx="9994392" cy="365760"/>
-          </a:xfrm>
-          <a:prstGeom prst="rect">
-            <a:avLst/>
-          </a:prstGeom>
-          <a:noFill/>
-          <a:ln/>
-        </p:spPr>
-        <p:txBody>
-          <a:bodyPr wrap="square" lIns="0" tIns="0" rIns="0" bIns="0" rtlCol="0" anchor="ctr"/>
-          <a:lstStyle/>
-          <a:p>
-            <a:pPr algn="ctr" indent="0" marL="0">
-              <a:buNone/>
-            </a:pPr>
-            <a:r>
-              <a:rPr lang="en-US" sz="1200" u="sng" dirty="0">
-                <a:solidFill>
-                  <a:srgbClr val="E4572E"/>
-                </a:solidFill>
-                <a:latin typeface="Calibri" pitchFamily="34" charset="0"/>
-                <a:ea typeface="Calibri" pitchFamily="34" charset="-122"/>
-                <a:cs typeface="Calibri" pitchFamily="34" charset="-120"/>
-                <a:hlinkClick r:id="rId1" invalidUrl="" action="" tgtFrame="" tooltip="" history="1" highlightClick="0" endSnd="0">
-                  <a:extLst>
-                    <a:ext uri="{A12FA001-AC4F-418D-AE19-62706E023703}">
-                      <ahyp:hlinkClr xmlns:ahyp="http://schemas.microsoft.com/office/drawing/2018/hyperlinkcolor" val="tx"/>
-                    </a:ext>
-                  </a:extLst>
-                </a:hlinkClick>
-              </a:rPr>
-              <a:t>https://www.youtube.com/watch?v=BaFkbNOaof8</a:t>
-            </a:r>
-            <a:endParaRPr lang="en-US" sz="1200" dirty="0"/>
-          </a:p>
-        </p:txBody>
-      </p:sp>
-      <p:sp>
-        <p:nvSpPr>
-          <p:cNvPr id="10" name="Text 8"/>
-          <p:cNvSpPr txBox="1"/>
-          <p:nvPr/>
-        </p:nvSpPr>
-        <p:spPr>
-          <a:xfrm>
-            <a:off x="548640" y="5257800"/>
-            <a:ext cx="11091672" cy="914400"/>
-          </a:xfrm>
-          <a:prstGeom prst="rect">
-            <a:avLst/>
-          </a:prstGeom>
-          <a:noFill/>
-          <a:ln/>
-        </p:spPr>
-        <p:txBody>
-          <a:bodyPr wrap="square" lIns="0" tIns="0" rIns="0" bIns="0" rtlCol="0" anchor="t"/>
-          <a:lstStyle/>
-          <a:p>
-            <a:pPr indent="0" marL="0">
-              <a:lnSpc>
-                <a:spcPct val="125000"/>
-              </a:lnSpc>
-              <a:buNone/>
-            </a:pPr>
-            <a:r>
-              <a:rPr lang="en-US" sz="1400" i="1" dirty="0">
-                <a:solidFill>
-                  <a:srgbClr val="27496D"/>
-                </a:solidFill>
-                <a:latin typeface="Calibri" pitchFamily="34" charset="0"/>
-                <a:ea typeface="Calibri" pitchFamily="34" charset="-122"/>
-                <a:cs typeface="Calibri" pitchFamily="34" charset="-120"/>
-              </a:rPr>
-              <a:t>Watch this before Lab 1 if today's pipeline felt unfamiliar.</a:t>
-            </a:r>
-            <a:endParaRPr lang="en-US" sz="1400" dirty="0"/>
-          </a:p>
-        </p:txBody>
-      </p:sp>
-    </p:spTree>
-  </p:cSld>
-  <p:clrMapOvr>
-    <a:masterClrMapping/>
-  </p:clrMapOvr>
-  <p:transition xmlns:p="http://schemas.openxmlformats.org/presentationml/2006/main" spd="med">
-    <p:fade/>
-  </p:transition>
-</p:sld>
-</file>
-
 <file path=ppt/slides/slide16.xml><?xml version="1.0" encoding="utf-8"?>
 <p:sld xmlns:a="http://schemas.openxmlformats.org/drawingml/2006/main" xmlns:r="http://schemas.openxmlformats.org/officeDocument/2006/relationships" xmlns:p="http://schemas.openxmlformats.org/presentationml/2006/main">
   <p:cSld name="Slide 16">
@@ -7355,7 +6574,7 @@
                 <a:ea typeface="Calibri" pitchFamily="34" charset="-122"/>
                 <a:cs typeface="Calibri" pitchFamily="34" charset="-120"/>
               </a:rPr>
-              <a:t>What this course adds on the undergraduate course, how to set up pacman and dplyr, and a real dplyr pipeline on real 2017-18 data.</a:t>
+              <a:t>What this course covers, how to set up pacman and dplyr, and a real dplyr pipeline on real 2017-18 data.</a:t>
             </a:r>
             <a:endParaRPr lang="en-US" sz="1400" dirty="0"/>
           </a:p>
@@ -11633,7 +10852,7 @@
                 <a:ea typeface="Calibri" pitchFamily="34" charset="-122"/>
                 <a:cs typeface="Calibri" pitchFamily="34" charset="-120"/>
               </a:rPr>
-              <a:t>What this course adds on the undergraduate course, and getting our tools set up</a:t>
+              <a:t>What this course covers, and getting our tools set up</a:t>
             </a:r>
             <a:endParaRPr lang="en-US" sz="1200" dirty="0"/>
           </a:p>
@@ -12059,7 +11278,7 @@
                 <a:ea typeface="Calibri" pitchFamily="34" charset="-122"/>
                 <a:cs typeface="Calibri" pitchFamily="34" charset="-120"/>
               </a:rPr>
-              <a:t>Homework 1 and the Module 1 lab</a:t>
+              <a:t>The Module 1 lab and quiz</a:t>
             </a:r>
             <a:endParaRPr lang="en-US" sz="1200" dirty="0"/>
           </a:p>
@@ -12917,7 +12136,7 @@
                 <a:ea typeface="Calibri" pitchFamily="34" charset="-122"/>
                 <a:cs typeface="Calibri" pitchFamily="34" charset="-120"/>
               </a:rPr>
-              <a:t>Homework Assignment</a:t>
+              <a:t>Course-Wide Assignments</a:t>
             </a:r>
             <a:endParaRPr lang="en-US" sz="1500" dirty="0"/>
           </a:p>
@@ -12956,7 +12175,7 @@
                 <a:ea typeface="Calibri" pitchFamily="34" charset="-122"/>
                 <a:cs typeface="Calibri" pitchFamily="34" charset="-120"/>
               </a:rPr>
-              <a:t>The graded work -- 4-5 problems, real code and real output required, one visualization you build yourself.</a:t>
+              <a:t>3 assignments, a midterm project, and a final project run at set points across the whole semester, graded and hand-checked -- not one per module.</a:t>
             </a:r>
             <a:endParaRPr lang="en-US" sz="1400" dirty="0"/>
           </a:p>
@@ -13059,261 +12278,6 @@
               <a:t>Short, D2L-based check of the module's key definitions.</a:t>
             </a:r>
             <a:endParaRPr lang="en-US" sz="1400" dirty="0"/>
-          </a:p>
-        </p:txBody>
-      </p:sp>
-    </p:spTree>
-  </p:cSld>
-  <p:clrMapOvr>
-    <a:masterClrMapping/>
-  </p:clrMapOvr>
-  <p:transition xmlns:p="http://schemas.openxmlformats.org/presentationml/2006/main" spd="med">
-    <p:fade/>
-  </p:transition>
-</p:sld>
-</file>
-
-<file path=ppt/slides/slide34.xml><?xml version="1.0" encoding="utf-8"?>
-<p:sld xmlns:a="http://schemas.openxmlformats.org/drawingml/2006/main" xmlns:r="http://schemas.openxmlformats.org/officeDocument/2006/relationships" xmlns:p="http://schemas.openxmlformats.org/presentationml/2006/main">
-  <p:cSld name="Slide 34">
-    <p:bg>
-      <p:bgPr>
-        <a:solidFill>
-          <a:srgbClr val="FFFFFF"/>
-        </a:solidFill>
-      </p:bgPr>
-    </p:bg>
-    <p:spTree>
-      <p:nvGrpSpPr>
-        <p:cNvPr id="1" name=""/>
-        <p:cNvGrpSpPr/>
-        <p:nvPr/>
-      </p:nvGrpSpPr>
-      <p:grpSpPr>
-        <a:xfrm>
-          <a:off x="0" y="0"/>
-          <a:ext cx="0" cy="0"/>
-          <a:chOff x="0" y="0"/>
-          <a:chExt cx="0" cy="0"/>
-        </a:xfrm>
-      </p:grpSpPr>
-      <p:sp>
-        <p:nvSpPr>
-          <p:cNvPr id="2" name="Text 0"/>
-          <p:cNvSpPr txBox="1"/>
-          <p:nvPr/>
-        </p:nvSpPr>
-        <p:spPr>
-          <a:xfrm>
-            <a:off x="548640" y="411480"/>
-            <a:ext cx="11091672" cy="320040"/>
-          </a:xfrm>
-          <a:prstGeom prst="rect">
-            <a:avLst/>
-          </a:prstGeom>
-          <a:noFill/>
-          <a:ln/>
-        </p:spPr>
-        <p:txBody>
-          <a:bodyPr wrap="square" lIns="0" tIns="0" rIns="0" bIns="0" rtlCol="0" anchor="ctr"/>
-          <a:lstStyle/>
-          <a:p>
-            <a:pPr indent="0" marL="0">
-              <a:buNone/>
-            </a:pPr>
-            <a:r>
-              <a:rPr lang="en-US" sz="1300" b="1" spc="200" kern="0" dirty="0">
-                <a:solidFill>
-                  <a:srgbClr val="E4572E"/>
-                </a:solidFill>
-                <a:latin typeface="Calibri" pitchFamily="34" charset="0"/>
-                <a:ea typeface="Calibri" pitchFamily="34" charset="-122"/>
-                <a:cs typeface="Calibri" pitchFamily="34" charset="-120"/>
-              </a:rPr>
-              <a:t>HOMEWORK ASSIGNMENT 1</a:t>
-            </a:r>
-            <a:endParaRPr lang="en-US" sz="1300" dirty="0"/>
-          </a:p>
-        </p:txBody>
-      </p:sp>
-      <p:sp>
-        <p:nvSpPr>
-          <p:cNvPr id="3" name="Text 1"/>
-          <p:cNvSpPr txBox="1"/>
-          <p:nvPr/>
-        </p:nvSpPr>
-        <p:spPr>
-          <a:xfrm>
-            <a:off x="548640" y="960120"/>
-            <a:ext cx="11091672" cy="914400"/>
-          </a:xfrm>
-          <a:prstGeom prst="rect">
-            <a:avLst/>
-          </a:prstGeom>
-          <a:noFill/>
-          <a:ln/>
-        </p:spPr>
-        <p:txBody>
-          <a:bodyPr wrap="square" lIns="0" tIns="0" rIns="0" bIns="0" rtlCol="0" anchor="ctr"/>
-          <a:lstStyle/>
-          <a:p>
-            <a:pPr indent="0" marL="0">
-              <a:buNone/>
-            </a:pPr>
-            <a:r>
-              <a:rPr lang="en-US" sz="2800" b="1" dirty="0">
-                <a:solidFill>
-                  <a:srgbClr val="16213E"/>
-                </a:solidFill>
-                <a:latin typeface="Cambria" pitchFamily="34" charset="0"/>
-                <a:ea typeface="Cambria" pitchFamily="34" charset="-122"/>
-                <a:cs typeface="Cambria" pitchFamily="34" charset="-120"/>
-              </a:rPr>
-              <a:t>What's In Your First Assignment</a:t>
-            </a:r>
-            <a:endParaRPr lang="en-US" sz="2800" dirty="0"/>
-          </a:p>
-        </p:txBody>
-      </p:sp>
-      <p:sp>
-        <p:nvSpPr>
-          <p:cNvPr id="4" name="Shape 2"/>
-          <p:cNvSpPr/>
-          <p:nvPr/>
-        </p:nvSpPr>
-        <p:spPr>
-          <a:xfrm>
-            <a:off x="548640" y="2103120"/>
-            <a:ext cx="11091672" cy="2377440"/>
-          </a:xfrm>
-          <a:prstGeom prst="roundRect">
-            <a:avLst>
-              <a:gd name="adj" fmla="val 2308"/>
-            </a:avLst>
-          </a:prstGeom>
-          <a:solidFill>
-            <a:srgbClr val="E4572E"/>
-          </a:solidFill>
-          <a:ln/>
-        </p:spPr>
-      </p:sp>
-      <p:sp>
-        <p:nvSpPr>
-          <p:cNvPr id="5" name="Text 3"/>
-          <p:cNvSpPr txBox="1"/>
-          <p:nvPr/>
-        </p:nvSpPr>
-        <p:spPr>
-          <a:xfrm>
-            <a:off x="914400" y="2331720"/>
-            <a:ext cx="10360152" cy="457200"/>
-          </a:xfrm>
-          <a:prstGeom prst="rect">
-            <a:avLst/>
-          </a:prstGeom>
-          <a:noFill/>
-          <a:ln/>
-        </p:spPr>
-        <p:txBody>
-          <a:bodyPr wrap="square" lIns="0" tIns="0" rIns="0" bIns="0" rtlCol="0" anchor="ctr"/>
-          <a:lstStyle/>
-          <a:p>
-            <a:pPr indent="0" marL="0">
-              <a:buNone/>
-            </a:pPr>
-            <a:r>
-              <a:rPr lang="en-US" sz="1500" b="1" dirty="0">
-                <a:solidFill>
-                  <a:srgbClr val="FFFFFF"/>
-                </a:solidFill>
-                <a:latin typeface="Calibri" pitchFamily="34" charset="0"/>
-                <a:ea typeface="Calibri" pitchFamily="34" charset="-122"/>
-                <a:cs typeface="Calibri" pitchFamily="34" charset="-120"/>
-              </a:rPr>
-              <a:t>Due: -- set by instructor before posting --</a:t>
-            </a:r>
-            <a:endParaRPr lang="en-US" sz="1500" dirty="0"/>
-          </a:p>
-        </p:txBody>
-      </p:sp>
-      <p:sp>
-        <p:nvSpPr>
-          <p:cNvPr id="6" name="Text 4"/>
-          <p:cNvSpPr txBox="1"/>
-          <p:nvPr/>
-        </p:nvSpPr>
-        <p:spPr>
-          <a:xfrm>
-            <a:off x="914400" y="2880360"/>
-            <a:ext cx="10360152" cy="1463040"/>
-          </a:xfrm>
-          <a:prstGeom prst="rect">
-            <a:avLst/>
-          </a:prstGeom>
-          <a:noFill/>
-          <a:ln/>
-        </p:spPr>
-        <p:txBody>
-          <a:bodyPr wrap="square" lIns="0" tIns="0" rIns="0" bIns="0" rtlCol="0" anchor="ctr"/>
-          <a:lstStyle/>
-          <a:p>
-            <a:pPr indent="0" marL="0">
-              <a:lnSpc>
-                <a:spcPct val="130000"/>
-              </a:lnSpc>
-              <a:buNone/>
-            </a:pPr>
-            <a:r>
-              <a:rPr lang="en-US" sz="1600" dirty="0">
-                <a:solidFill>
-                  <a:srgbClr val="FFFFFF"/>
-                </a:solidFill>
-                <a:latin typeface="Calibri" pitchFamily="34" charset="0"/>
-                <a:ea typeface="Calibri" pitchFamily="34" charset="-122"/>
-                <a:cs typeface="Calibri" pitchFamily="34" charset="-120"/>
-              </a:rPr>
-              <a:t>Five problems, 20 points each: two conceptual questions on this module's ideas, a dplyr pipeline problem on new real data, an assist-network problem on a different team, and one interpretation question with no single obvious right answer.</a:t>
-            </a:r>
-            <a:endParaRPr lang="en-US" sz="1600" dirty="0"/>
-          </a:p>
-        </p:txBody>
-      </p:sp>
-      <p:sp>
-        <p:nvSpPr>
-          <p:cNvPr id="7" name="Text 5"/>
-          <p:cNvSpPr txBox="1"/>
-          <p:nvPr/>
-        </p:nvSpPr>
-        <p:spPr>
-          <a:xfrm>
-            <a:off x="548640" y="6355080"/>
-            <a:ext cx="11091672" cy="365760"/>
-          </a:xfrm>
-          <a:prstGeom prst="rect">
-            <a:avLst/>
-          </a:prstGeom>
-          <a:noFill/>
-          <a:ln/>
-        </p:spPr>
-        <p:txBody>
-          <a:bodyPr wrap="square" lIns="0" tIns="0" rIns="0" bIns="0" rtlCol="0" anchor="ctr"/>
-          <a:lstStyle/>
-          <a:p>
-            <a:pPr indent="0" marL="0">
-              <a:buNone/>
-            </a:pPr>
-            <a:r>
-              <a:rPr lang="en-US" sz="1000" dirty="0">
-                <a:solidFill>
-                  <a:srgbClr val="6B7A99"/>
-                </a:solidFill>
-                <a:latin typeface="Calibri" pitchFamily="34" charset="0"/>
-                <a:ea typeface="Calibri" pitchFamily="34" charset="-122"/>
-                <a:cs typeface="Calibri" pitchFamily="34" charset="-120"/>
-              </a:rPr>
-              <a:t>Full problem set: Homework_Assignment/Module_01_Assignment.md</a:t>
-            </a:r>
-            <a:endParaRPr lang="en-US" sz="1000" dirty="0"/>
           </a:p>
         </p:txBody>
       </p:sp>
@@ -13699,7 +12663,7 @@
                 <a:ea typeface="Calibri" pitchFamily="34" charset="-122"/>
                 <a:cs typeface="Calibri" pitchFamily="34" charset="-120"/>
               </a:rPr>
-              <a:t>Set up the tools this course runs on: pacman, dplyr, and the same BasketballAnalyzeR package from the undergraduate course.</a:t>
+              <a:t>Set up the tools this course runs on: pacman, dplyr, and the BasketballAnalyzeR package.</a:t>
             </a:r>
             <a:endParaRPr lang="en-US" sz="1600" dirty="0"/>
           </a:p>
@@ -14302,7 +13266,7 @@
                 <a:ea typeface="Calibri" pitchFamily="34" charset="-122"/>
                 <a:cs typeface="Calibri" pitchFamily="34" charset="-120"/>
               </a:rPr>
-              <a:t>Homework Assignment 1 (see the due date once it's posted).</a:t>
+              <a:t>Practice questions in this module's folder, any time you want extra reps.</a:t>
             </a:r>
             <a:endParaRPr lang="en-US" sz="1600" dirty="0"/>
           </a:p>
@@ -14498,7 +13462,7 @@
                 <a:ea typeface="Calibri" pitchFamily="34" charset="-122"/>
                 <a:cs typeface="Calibri" pitchFamily="34" charset="-120"/>
               </a:rPr>
-              <a:t>If dplyr syntax still feels unfamiliar, watch the video from Segment 1 before Lab 1.</a:t>
+              <a:t>Bring one question about today's material to next class -- we'll open with it.</a:t>
             </a:r>
             <a:endParaRPr lang="en-US" sz="1600" dirty="0"/>
           </a:p>
@@ -14743,48 +13707,6 @@
           </a:p>
         </p:txBody>
       </p:sp>
-      <p:sp>
-        <p:nvSpPr>
-          <p:cNvPr id="7" name="Text 5"/>
-          <p:cNvSpPr txBox="1"/>
-          <p:nvPr/>
-        </p:nvSpPr>
-        <p:spPr>
-          <a:xfrm>
-            <a:off x="548640" y="4663440"/>
-            <a:ext cx="11091672" cy="914400"/>
-          </a:xfrm>
-          <a:prstGeom prst="rect">
-            <a:avLst/>
-          </a:prstGeom>
-          <a:noFill/>
-          <a:ln/>
-        </p:spPr>
-        <p:txBody>
-          <a:bodyPr wrap="square" lIns="0" tIns="0" rIns="0" bIns="0" rtlCol="0" anchor="t"/>
-          <a:lstStyle/>
-          <a:p>
-            <a:pPr indent="0" marL="0">
-              <a:lnSpc>
-                <a:spcPct val="130000"/>
-              </a:lnSpc>
-              <a:buNone/>
-            </a:pPr>
-            <a:r>
-              <a:rPr lang="en-US" sz="1300" dirty="0">
-                <a:solidFill>
-                  <a:srgbClr val="16213E"/>
-                </a:solidFill>
-                <a:latin typeface="Calibri" pitchFamily="34" charset="0"/>
-                <a:ea typeface="Calibri" pitchFamily="34" charset="-122"/>
-                <a:cs typeface="Calibri" pitchFamily="34" charset="-120"/>
-              </a:rPr>
-              <a:t>R PROGRAMMING dplyr BASICS -- summarize, group_by, select, mutate, filter, arrange. YouTube. https://www.youtube.com/watch?v=BaFkbNOaof8</a:t>
-            </a:r>
-            <a:endParaRPr lang="en-US" sz="1300" dirty="0"/>
-          </a:p>
-        </p:txBody>
-      </p:sp>
     </p:spTree>
   </p:cSld>
   <p:clrMapOvr>
@@ -15103,7 +14025,7 @@
                 <a:ea typeface="Calibri" pitchFamily="34" charset="-122"/>
                 <a:cs typeface="Calibri" pitchFamily="34" charset="-120"/>
               </a:rPr>
-              <a:t>Explain what this course adds on top of the undergraduate course, and set up the R environment the rest of the semester runs on.</a:t>
+              <a:t>Explain what this course covers, and set up the R environment the rest of the semester runs on.</a:t>
             </a:r>
             <a:endParaRPr lang="en-US" sz="1600" dirty="0"/>
           </a:p>
@@ -15495,7 +14417,7 @@
                 <a:ea typeface="Calibri" pitchFamily="34" charset="-122"/>
                 <a:cs typeface="Calibri" pitchFamily="34" charset="-120"/>
               </a:rPr>
-              <a:t>Understand the structure and expectations of this course's graded Homework Assignments.</a:t>
+              <a:t>Understand how this course's quizzes, assignments, and projects fit together across the semester.</a:t>
             </a:r>
             <a:endParaRPr lang="en-US" sz="1600" dirty="0"/>
           </a:p>
@@ -15672,7 +14594,7 @@
                 <a:ea typeface="Calibri" pitchFamily="34" charset="-122"/>
                 <a:cs typeface="Calibri" pitchFamily="34" charset="-120"/>
               </a:rPr>
-              <a:t>This course picks up exactly where the undergraduate course left off, using the same BasketballAnalyzeR package you already know, and adds the tools from the book's own second step: statistical models, data mining, machine learning, and computer vision, applied to basketball.</a:t>
+              <a:t>This course runs on the BasketballAnalyzeR package throughout, and adds the tools from the book's own second step: statistical models, data mining, machine learning, and computer vision, applied to basketball.</a:t>
             </a:r>
             <a:endParaRPr lang="en-US" sz="1600" dirty="0"/>
           </a:p>

</xml_diff>